<commit_message>
S01+S02 ancladas a producto real / early access
</commit_message>
<xml_diff>
--- a/Domingo-14/S01_Domingo-14_1_Post_El-pendiente-de-la-semana_1x1.pptx
+++ b/Domingo-14/S01_Domingo-14_1_Post_El-pendiente-de-la-semana_1x1.pptx
@@ -3285,7 +3285,7 @@
         </p:nvSpPr>
         <p:spPr>
           <a:xfrm>
-            <a:off x="777240" y="1280160"/>
+            <a:off x="777240" y="1494536"/>
             <a:ext cx="1371600" cy="146304"/>
           </a:xfrm>
           <a:prstGeom prst="rect">
@@ -3329,8 +3329,8 @@
         </p:nvSpPr>
         <p:spPr>
           <a:xfrm>
-            <a:off x="777240" y="1737360"/>
-            <a:ext cx="6675120" cy="4737608"/>
+            <a:off x="777240" y="1951736"/>
+            <a:ext cx="6675120" cy="3594608"/>
           </a:xfrm>
           <a:prstGeom prst="rect">
             <a:avLst/>
@@ -3349,7 +3349,7 @@
               </a:lnSpc>
             </a:pPr>
             <a:r>
-              <a:rPr sz="5600" b="1">
+              <a:rPr sz="5200" b="1">
                 <a:solidFill>
                   <a:srgbClr val="FFFFFF"/>
                 </a:solidFill>
@@ -3363,6 +3363,45 @@
       <p:sp>
         <p:nvSpPr>
           <p:cNvPr id="8" name="TextBox 7"/>
+          <p:cNvSpPr txBox="1"/>
+          <p:nvPr/>
+        </p:nvSpPr>
+        <p:spPr>
+          <a:xfrm>
+            <a:off x="777240" y="5546344"/>
+            <a:ext cx="6675120" cy="1118108"/>
+          </a:xfrm>
+          <a:prstGeom prst="rect">
+            <a:avLst/>
+          </a:prstGeom>
+          <a:noFill/>
+        </p:spPr>
+        <p:txBody>
+          <a:bodyPr wrap="square" anchor="t" lIns="0" rIns="0" tIns="0" bIns="0">
+            <a:spAutoFit/>
+          </a:bodyPr>
+          <a:lstStyle/>
+          <a:p>
+            <a:pPr algn="l">
+              <a:lnSpc>
+                <a:spcPct val="110000"/>
+              </a:lnSpc>
+            </a:pPr>
+            <a:r>
+              <a:rPr sz="2600" b="0">
+                <a:solidFill>
+                  <a:srgbClr val="FFFFFF"/>
+                </a:solidFill>
+                <a:latin typeface="Inter"/>
+              </a:rPr>
+              <a:t>Resuélvelo hoy en notaly.com.ve</a:t>
+            </a:r>
+          </a:p>
+        </p:txBody>
+      </p:sp>
+      <p:sp>
+        <p:nvSpPr>
+          <p:cNvPr id="9" name="TextBox 8"/>
           <p:cNvSpPr txBox="1"/>
           <p:nvPr/>
         </p:nvSpPr>

</xml_diff>